<commit_message>
Regenere derivados da apresentação com ReportLab
</commit_message>
<xml_diff>
--- a/_SAMPLES_ENTREGAVEIS/executive_presentation/sample-executive-presentation-v1.0.0.pptx
+++ b/_SAMPLES_ENTREGAVEIS/executive_presentation/sample-executive-presentation-v1.0.0.pptx
@@ -13,7 +13,7 @@
     <p:sldId id="261" r:id="rId12"/>
     <p:sldId id="262" r:id="rId13"/>
   </p:sldIdLst>
-  <p:sldSz cx="12191695" cy="6858000" type="screen4x3"/>
+  <p:sldSz cx="12191760" cy="6858000" type="screen4x3"/>
   <p:notesSz cx="6858000" cy="9144000"/>
   <p:defaultTextStyle>
     <a:defPPr>
@@ -3126,7 +3126,7 @@
         </p:nvSpPr>
         <p:spPr>
           <a:xfrm>
-            <a:off x="457200" y="457200"/>
+            <a:off x="457199" y="457199"/>
             <a:ext cx="9418320" cy="731520"/>
           </a:xfrm>
           <a:prstGeom prst="rect">
@@ -3141,7 +3141,7 @@
           <a:lstStyle/>
           <a:p>
             <a:r>
-              <a:rPr sz="2800">
+              <a:rPr sz="2400">
                 <a:solidFill>
                   <a:srgbClr val="193C8E"/>
                 </a:solidFill>
@@ -3160,7 +3160,7 @@
         </p:nvSpPr>
         <p:spPr>
           <a:xfrm>
-            <a:off x="548640" y="1417320"/>
+            <a:off x="548640" y="1417319"/>
             <a:ext cx="11064240" cy="4892040"/>
           </a:xfrm>
           <a:prstGeom prst="roundRect">
@@ -3200,6 +3200,42 @@
             </a:pPr>
             <a:r>
               <a:t>Amostra de validação visual e estrutural. Dados, pessoas, votos e resultados são fictícios.</a:t>
+            </a:r>
+          </a:p>
+        </p:txBody>
+      </p:sp>
+      <p:sp>
+        <p:nvSpPr>
+          <p:cNvPr id="5" name="TextBox 4"/>
+          <p:cNvSpPr txBox="1"/>
+          <p:nvPr/>
+        </p:nvSpPr>
+        <p:spPr>
+          <a:xfrm>
+            <a:off x="548640" y="6419160"/>
+            <a:ext cx="11064240" cy="301680"/>
+          </a:xfrm>
+          <a:prstGeom prst="rect">
+            <a:avLst/>
+          </a:prstGeom>
+          <a:noFill/>
+        </p:spPr>
+        <p:txBody>
+          <a:bodyPr wrap="square">
+            <a:spAutoFit/>
+          </a:bodyPr>
+          <a:lstStyle/>
+          <a:p>
+            <a:pPr>
+              <a:defRPr sz="1000">
+                <a:solidFill>
+                  <a:srgbClr val="586EA4"/>
+                </a:solidFill>
+                <a:latin typeface="Roboto"/>
+              </a:defRPr>
+            </a:pPr>
+            <a:r>
+              <a:t>ID sample-executive-presentation · versão 1.0.0 · Completo</a:t>
             </a:r>
           </a:p>
         </p:txBody>
@@ -3254,7 +3290,7 @@
         </p:nvSpPr>
         <p:spPr>
           <a:xfrm>
-            <a:off x="457200" y="457200"/>
+            <a:off x="457199" y="457199"/>
             <a:ext cx="9418320" cy="731520"/>
           </a:xfrm>
           <a:prstGeom prst="rect">
@@ -3269,13 +3305,13 @@
           <a:lstStyle/>
           <a:p>
             <a:r>
-              <a:rPr sz="2800">
+              <a:rPr sz="2400">
                 <a:solidFill>
                   <a:srgbClr val="193C8E"/>
                 </a:solidFill>
                 <a:latin typeface="Montserrat"/>
               </a:rPr>
-              <a:t>Contexto</a:t>
+              <a:t>A jornada fictícia delimita o problema e a hipótese</a:t>
             </a:r>
           </a:p>
         </p:txBody>
@@ -3288,7 +3324,7 @@
         </p:nvSpPr>
         <p:spPr>
           <a:xfrm>
-            <a:off x="548640" y="1417320"/>
+            <a:off x="548640" y="1417319"/>
             <a:ext cx="11064240" cy="4892040"/>
           </a:xfrm>
           <a:prstGeom prst="roundRect">
@@ -3328,6 +3364,42 @@
             </a:pPr>
             <a:r>
               <a:t>Exemplo fictício de jornada de solicitações de dados. Hipótese, usuários e escopo são demonstrativos. [FIC-01]</a:t>
+            </a:r>
+          </a:p>
+        </p:txBody>
+      </p:sp>
+      <p:sp>
+        <p:nvSpPr>
+          <p:cNvPr id="5" name="TextBox 4"/>
+          <p:cNvSpPr txBox="1"/>
+          <p:nvPr/>
+        </p:nvSpPr>
+        <p:spPr>
+          <a:xfrm>
+            <a:off x="548640" y="6419160"/>
+            <a:ext cx="11064240" cy="301680"/>
+          </a:xfrm>
+          <a:prstGeom prst="rect">
+            <a:avLst/>
+          </a:prstGeom>
+          <a:noFill/>
+        </p:spPr>
+        <p:txBody>
+          <a:bodyPr wrap="square">
+            <a:spAutoFit/>
+          </a:bodyPr>
+          <a:lstStyle/>
+          <a:p>
+            <a:pPr>
+              <a:defRPr sz="1000">
+                <a:solidFill>
+                  <a:srgbClr val="586EA4"/>
+                </a:solidFill>
+                <a:latin typeface="Roboto"/>
+              </a:defRPr>
+            </a:pPr>
+            <a:r>
+              <a:t>ID sample-executive-presentation · versão 1.0.0 · Completo</a:t>
             </a:r>
           </a:p>
         </p:txBody>
@@ -3382,7 +3454,7 @@
         </p:nvSpPr>
         <p:spPr>
           <a:xfrm>
-            <a:off x="457200" y="457200"/>
+            <a:off x="457199" y="457199"/>
             <a:ext cx="9418320" cy="731520"/>
           </a:xfrm>
           <a:prstGeom prst="rect">
@@ -3397,13 +3469,13 @@
           <a:lstStyle/>
           <a:p>
             <a:r>
-              <a:rPr sz="2800">
+              <a:rPr sz="2400">
                 <a:solidFill>
                   <a:srgbClr val="193C8E"/>
                 </a:solidFill>
                 <a:latin typeface="Montserrat"/>
               </a:rPr>
-              <a:t>Método</a:t>
+              <a:t>O método combina compreensão da tarefa e piloto controlado</a:t>
             </a:r>
           </a:p>
         </p:txBody>
@@ -3416,7 +3488,7 @@
         </p:nvSpPr>
         <p:spPr>
           <a:xfrm>
-            <a:off x="548640" y="1417320"/>
+            <a:off x="548640" y="1417319"/>
             <a:ext cx="11064240" cy="4892040"/>
           </a:xfrm>
           <a:prstGeom prst="roundRect">
@@ -3456,6 +3528,42 @@
             </a:pPr>
             <a:r>
               <a:t>Teste moderado de tarefa para compreensão, seguido de piloto controlado para observar completude e tempo. Nenhuma coleta ocorreu neste exemplo. [FIC-01]</a:t>
+            </a:r>
+          </a:p>
+        </p:txBody>
+      </p:sp>
+      <p:sp>
+        <p:nvSpPr>
+          <p:cNvPr id="5" name="TextBox 4"/>
+          <p:cNvSpPr txBox="1"/>
+          <p:nvPr/>
+        </p:nvSpPr>
+        <p:spPr>
+          <a:xfrm>
+            <a:off x="548640" y="6419160"/>
+            <a:ext cx="11064240" cy="301680"/>
+          </a:xfrm>
+          <a:prstGeom prst="rect">
+            <a:avLst/>
+          </a:prstGeom>
+          <a:noFill/>
+        </p:spPr>
+        <p:txBody>
+          <a:bodyPr wrap="square">
+            <a:spAutoFit/>
+          </a:bodyPr>
+          <a:lstStyle/>
+          <a:p>
+            <a:pPr>
+              <a:defRPr sz="1000">
+                <a:solidFill>
+                  <a:srgbClr val="586EA4"/>
+                </a:solidFill>
+                <a:latin typeface="Roboto"/>
+              </a:defRPr>
+            </a:pPr>
+            <a:r>
+              <a:t>ID sample-executive-presentation · versão 1.0.0 · Completo</a:t>
             </a:r>
           </a:p>
         </p:txBody>
@@ -3510,7 +3618,7 @@
         </p:nvSpPr>
         <p:spPr>
           <a:xfrm>
-            <a:off x="457200" y="457200"/>
+            <a:off x="457199" y="457199"/>
             <a:ext cx="9418320" cy="731520"/>
           </a:xfrm>
           <a:prstGeom prst="rect">
@@ -3525,13 +3633,13 @@
           <a:lstStyle/>
           <a:p>
             <a:r>
-              <a:rPr sz="2800">
+              <a:rPr sz="2400">
                 <a:solidFill>
                   <a:srgbClr val="193C8E"/>
                 </a:solidFill>
                 <a:latin typeface="Montserrat"/>
               </a:rPr>
-              <a:t>Achados</a:t>
+              <a:t>A orientação reduziu dúvidas, mas o efeito real não foi medido</a:t>
             </a:r>
           </a:p>
         </p:txBody>
@@ -3544,7 +3652,7 @@
         </p:nvSpPr>
         <p:spPr>
           <a:xfrm>
-            <a:off x="548640" y="1417320"/>
+            <a:off x="548640" y="1417319"/>
             <a:ext cx="11064240" cy="4892040"/>
           </a:xfrm>
           <a:prstGeom prst="roundRect">
@@ -3584,6 +3692,42 @@
             </a:pPr>
             <a:r>
               <a:t>Achado ilustrativo: a orientação reduziu dúvidas no protótipo, mas não existe evidência real de efeito operacional. [FIC-01]</a:t>
+            </a:r>
+          </a:p>
+        </p:txBody>
+      </p:sp>
+      <p:sp>
+        <p:nvSpPr>
+          <p:cNvPr id="5" name="TextBox 4"/>
+          <p:cNvSpPr txBox="1"/>
+          <p:nvPr/>
+        </p:nvSpPr>
+        <p:spPr>
+          <a:xfrm>
+            <a:off x="548640" y="6419160"/>
+            <a:ext cx="11064240" cy="301680"/>
+          </a:xfrm>
+          <a:prstGeom prst="rect">
+            <a:avLst/>
+          </a:prstGeom>
+          <a:noFill/>
+        </p:spPr>
+        <p:txBody>
+          <a:bodyPr wrap="square">
+            <a:spAutoFit/>
+          </a:bodyPr>
+          <a:lstStyle/>
+          <a:p>
+            <a:pPr>
+              <a:defRPr sz="1000">
+                <a:solidFill>
+                  <a:srgbClr val="586EA4"/>
+                </a:solidFill>
+                <a:latin typeface="Roboto"/>
+              </a:defRPr>
+            </a:pPr>
+            <a:r>
+              <a:t>ID sample-executive-presentation · versão 1.0.0 · Completo</a:t>
             </a:r>
           </a:p>
         </p:txBody>
@@ -3638,7 +3782,7 @@
         </p:nvSpPr>
         <p:spPr>
           <a:xfrm>
-            <a:off x="457200" y="457200"/>
+            <a:off x="457199" y="457199"/>
             <a:ext cx="9418320" cy="731520"/>
           </a:xfrm>
           <a:prstGeom prst="rect">
@@ -3653,13 +3797,13 @@
           <a:lstStyle/>
           <a:p>
             <a:r>
-              <a:rPr sz="2800">
+              <a:rPr sz="2400">
                 <a:solidFill>
                   <a:srgbClr val="193C8E"/>
                 </a:solidFill>
                 <a:latin typeface="Montserrat"/>
               </a:rPr>
-              <a:t>Recomendação</a:t>
+              <a:t>Investigar causas e volumes antes de comprometer a construção</a:t>
             </a:r>
           </a:p>
         </p:txBody>
@@ -3672,7 +3816,7 @@
         </p:nvSpPr>
         <p:spPr>
           <a:xfrm>
-            <a:off x="548640" y="1417320"/>
+            <a:off x="548640" y="1417319"/>
             <a:ext cx="11064240" cy="4892040"/>
           </a:xfrm>
           <a:prstGeom prst="roundRect">
@@ -3712,6 +3856,42 @@
             </a:pPr>
             <a:r>
               <a:t>Investigar volumes e causas antes de comprometer construção. Nenhuma decisão real foi tomada neste exemplo. [FIC-01]</a:t>
+            </a:r>
+          </a:p>
+        </p:txBody>
+      </p:sp>
+      <p:sp>
+        <p:nvSpPr>
+          <p:cNvPr id="5" name="TextBox 4"/>
+          <p:cNvSpPr txBox="1"/>
+          <p:nvPr/>
+        </p:nvSpPr>
+        <p:spPr>
+          <a:xfrm>
+            <a:off x="548640" y="6419160"/>
+            <a:ext cx="11064240" cy="301680"/>
+          </a:xfrm>
+          <a:prstGeom prst="rect">
+            <a:avLst/>
+          </a:prstGeom>
+          <a:noFill/>
+        </p:spPr>
+        <p:txBody>
+          <a:bodyPr wrap="square">
+            <a:spAutoFit/>
+          </a:bodyPr>
+          <a:lstStyle/>
+          <a:p>
+            <a:pPr>
+              <a:defRPr sz="1000">
+                <a:solidFill>
+                  <a:srgbClr val="586EA4"/>
+                </a:solidFill>
+                <a:latin typeface="Roboto"/>
+              </a:defRPr>
+            </a:pPr>
+            <a:r>
+              <a:t>ID sample-executive-presentation · versão 1.0.0 · Completo</a:t>
             </a:r>
           </a:p>
         </p:txBody>
@@ -3766,7 +3946,7 @@
         </p:nvSpPr>
         <p:spPr>
           <a:xfrm>
-            <a:off x="457200" y="457200"/>
+            <a:off x="457199" y="457199"/>
             <a:ext cx="9418320" cy="731520"/>
           </a:xfrm>
           <a:prstGeom prst="rect">
@@ -3781,13 +3961,13 @@
           <a:lstStyle/>
           <a:p>
             <a:r>
-              <a:rPr sz="2800">
+              <a:rPr sz="2400">
                 <a:solidFill>
                   <a:srgbClr val="193C8E"/>
                 </a:solidFill>
                 <a:latin typeface="Montserrat"/>
               </a:rPr>
-              <a:t>Próximos passos</a:t>
+              <a:t>Uma rodada real deve preceder a decisão de escala</a:t>
             </a:r>
           </a:p>
         </p:txBody>
@@ -3800,7 +3980,7 @@
         </p:nvSpPr>
         <p:spPr>
           <a:xfrm>
-            <a:off x="548640" y="1417320"/>
+            <a:off x="548640" y="1417319"/>
             <a:ext cx="11064240" cy="4892040"/>
           </a:xfrm>
           <a:prstGeom prst="roundRect">
@@ -3840,6 +4020,42 @@
             </a:pPr>
             <a:r>
               <a:t>Consolidar linha de base, fechar Test Cards e executar uma rodada real antes de decidir escala. [FIC-01]</a:t>
+            </a:r>
+          </a:p>
+        </p:txBody>
+      </p:sp>
+      <p:sp>
+        <p:nvSpPr>
+          <p:cNvPr id="5" name="TextBox 4"/>
+          <p:cNvSpPr txBox="1"/>
+          <p:nvPr/>
+        </p:nvSpPr>
+        <p:spPr>
+          <a:xfrm>
+            <a:off x="548640" y="6419160"/>
+            <a:ext cx="11064240" cy="301680"/>
+          </a:xfrm>
+          <a:prstGeom prst="rect">
+            <a:avLst/>
+          </a:prstGeom>
+          <a:noFill/>
+        </p:spPr>
+        <p:txBody>
+          <a:bodyPr wrap="square">
+            <a:spAutoFit/>
+          </a:bodyPr>
+          <a:lstStyle/>
+          <a:p>
+            <a:pPr>
+              <a:defRPr sz="1000">
+                <a:solidFill>
+                  <a:srgbClr val="586EA4"/>
+                </a:solidFill>
+                <a:latin typeface="Roboto"/>
+              </a:defRPr>
+            </a:pPr>
+            <a:r>
+              <a:t>ID sample-executive-presentation · versão 1.0.0 · Completo</a:t>
             </a:r>
           </a:p>
         </p:txBody>
@@ -3894,7 +4110,7 @@
         </p:nvSpPr>
         <p:spPr>
           <a:xfrm>
-            <a:off x="457200" y="457200"/>
+            <a:off x="457199" y="457199"/>
             <a:ext cx="9418320" cy="731520"/>
           </a:xfrm>
           <a:prstGeom prst="rect">
@@ -3909,7 +4125,7 @@
           <a:lstStyle/>
           <a:p>
             <a:r>
-              <a:rPr sz="2800">
+              <a:rPr sz="2400">
                 <a:solidFill>
                   <a:srgbClr val="193C8E"/>
                 </a:solidFill>
@@ -3928,7 +4144,7 @@
         </p:nvSpPr>
         <p:spPr>
           <a:xfrm>
-            <a:off x="548640" y="1417320"/>
+            <a:off x="548640" y="1417319"/>
             <a:ext cx="11064240" cy="4892040"/>
           </a:xfrm>
           <a:prstGeom prst="roundRect">
@@ -3978,6 +4194,42 @@
             </a:pPr>
             <a:r>
               <a:t>FIC-02 — planilha-simulada, exemplo fictício, sem dados reais</a:t>
+            </a:r>
+          </a:p>
+        </p:txBody>
+      </p:sp>
+      <p:sp>
+        <p:nvSpPr>
+          <p:cNvPr id="5" name="TextBox 4"/>
+          <p:cNvSpPr txBox="1"/>
+          <p:nvPr/>
+        </p:nvSpPr>
+        <p:spPr>
+          <a:xfrm>
+            <a:off x="548640" y="6419160"/>
+            <a:ext cx="11064240" cy="301680"/>
+          </a:xfrm>
+          <a:prstGeom prst="rect">
+            <a:avLst/>
+          </a:prstGeom>
+          <a:noFill/>
+        </p:spPr>
+        <p:txBody>
+          <a:bodyPr wrap="square">
+            <a:spAutoFit/>
+          </a:bodyPr>
+          <a:lstStyle/>
+          <a:p>
+            <a:pPr>
+              <a:defRPr sz="1000">
+                <a:solidFill>
+                  <a:srgbClr val="586EA4"/>
+                </a:solidFill>
+                <a:latin typeface="Roboto"/>
+              </a:defRPr>
+            </a:pPr>
+            <a:r>
+              <a:t>ID sample-executive-presentation · versão 1.0.0 · Completo</a:t>
             </a:r>
           </a:p>
         </p:txBody>

</xml_diff>

<commit_message>
Alinha o logo à direita nos slides ReportLab e regenera a amostra
O slot logo do layout novo é a faixa do cabeçalho; como no HTML e no PPTX, o
logo cabe no slot e em 38 x 11 mm, alinhado à direita.

Co-Authored-By: Claude Opus 5.5 <noreply@anthropic.com>
</commit_message>
<xml_diff>
--- a/_SAMPLES_ENTREGAVEIS/executive_presentation/sample-executive-presentation-v1.0.0.pptx
+++ b/_SAMPLES_ENTREGAVEIS/executive_presentation/sample-executive-presentation-v1.0.0.pptx
@@ -13,7 +13,7 @@
     <p:sldId id="261" r:id="rId12"/>
     <p:sldId id="262" r:id="rId13"/>
   </p:sldIdLst>
-  <p:sldSz cx="12191760" cy="6858000" type="screen4x3"/>
+  <p:sldSz cx="12192120" cy="6858000" type="screen4x3"/>
   <p:notesSz cx="6858000" cy="9144000"/>
   <p:defaultTextStyle>
     <a:defPPr>
@@ -3110,8 +3110,8 @@
         </p:blipFill>
         <p:spPr>
           <a:xfrm>
-            <a:off x="10149840" y="320040"/>
-            <a:ext cx="1554480" cy="582765"/>
+            <a:off x="10571702" y="666000"/>
+            <a:ext cx="1056298" cy="396000"/>
           </a:xfrm>
           <a:prstGeom prst="rect">
             <a:avLst/>
@@ -3126,8 +3126,8 @@
         </p:nvSpPr>
         <p:spPr>
           <a:xfrm>
-            <a:off x="457199" y="457199"/>
-            <a:ext cx="9418320" cy="731520"/>
+            <a:off x="576000" y="1152000"/>
+            <a:ext cx="11052000" cy="864000"/>
           </a:xfrm>
           <a:prstGeom prst="rect">
             <a:avLst/>
@@ -3160,8 +3160,8 @@
         </p:nvSpPr>
         <p:spPr>
           <a:xfrm>
-            <a:off x="548640" y="1417319"/>
-            <a:ext cx="11064240" cy="4892040"/>
+            <a:off x="576000" y="2016000"/>
+            <a:ext cx="11052000" cy="3887999"/>
           </a:xfrm>
           <a:prstGeom prst="roundRect">
             <a:avLst/>
@@ -3195,6 +3195,9 @@
           <a:p>
             <a:pPr algn="ctr">
               <a:defRPr sz="1700">
+                <a:solidFill>
+                  <a:srgbClr val="30343B"/>
+                </a:solidFill>
                 <a:latin typeface="Roboto"/>
               </a:defRPr>
             </a:pPr>
@@ -3212,8 +3215,8 @@
         </p:nvSpPr>
         <p:spPr>
           <a:xfrm>
-            <a:off x="548640" y="6419160"/>
-            <a:ext cx="11064240" cy="301680"/>
+            <a:off x="576000" y="5904000"/>
+            <a:ext cx="11052000" cy="359999"/>
           </a:xfrm>
           <a:prstGeom prst="rect">
             <a:avLst/>
@@ -3274,8 +3277,8 @@
         </p:blipFill>
         <p:spPr>
           <a:xfrm>
-            <a:off x="10149840" y="320040"/>
-            <a:ext cx="1554480" cy="582765"/>
+            <a:off x="10571702" y="666000"/>
+            <a:ext cx="1056298" cy="396000"/>
           </a:xfrm>
           <a:prstGeom prst="rect">
             <a:avLst/>
@@ -3290,8 +3293,8 @@
         </p:nvSpPr>
         <p:spPr>
           <a:xfrm>
-            <a:off x="457199" y="457199"/>
-            <a:ext cx="9418320" cy="731520"/>
+            <a:off x="576000" y="1152000"/>
+            <a:ext cx="11052000" cy="864000"/>
           </a:xfrm>
           <a:prstGeom prst="rect">
             <a:avLst/>
@@ -3324,8 +3327,8 @@
         </p:nvSpPr>
         <p:spPr>
           <a:xfrm>
-            <a:off x="548640" y="1417319"/>
-            <a:ext cx="11064240" cy="4892040"/>
+            <a:off x="576000" y="2016000"/>
+            <a:ext cx="11052000" cy="3887999"/>
           </a:xfrm>
           <a:prstGeom prst="roundRect">
             <a:avLst/>
@@ -3359,6 +3362,9 @@
           <a:p>
             <a:pPr algn="ctr">
               <a:defRPr sz="1700">
+                <a:solidFill>
+                  <a:srgbClr val="30343B"/>
+                </a:solidFill>
                 <a:latin typeface="Roboto"/>
               </a:defRPr>
             </a:pPr>
@@ -3376,8 +3382,8 @@
         </p:nvSpPr>
         <p:spPr>
           <a:xfrm>
-            <a:off x="548640" y="6419160"/>
-            <a:ext cx="11064240" cy="301680"/>
+            <a:off x="576000" y="5904000"/>
+            <a:ext cx="11052000" cy="359999"/>
           </a:xfrm>
           <a:prstGeom prst="rect">
             <a:avLst/>
@@ -3438,8 +3444,8 @@
         </p:blipFill>
         <p:spPr>
           <a:xfrm>
-            <a:off x="10149840" y="320040"/>
-            <a:ext cx="1554480" cy="582765"/>
+            <a:off x="10571702" y="666000"/>
+            <a:ext cx="1056298" cy="396000"/>
           </a:xfrm>
           <a:prstGeom prst="rect">
             <a:avLst/>
@@ -3454,8 +3460,8 @@
         </p:nvSpPr>
         <p:spPr>
           <a:xfrm>
-            <a:off x="457199" y="457199"/>
-            <a:ext cx="9418320" cy="731520"/>
+            <a:off x="576000" y="1152000"/>
+            <a:ext cx="11052000" cy="864000"/>
           </a:xfrm>
           <a:prstGeom prst="rect">
             <a:avLst/>
@@ -3488,8 +3494,8 @@
         </p:nvSpPr>
         <p:spPr>
           <a:xfrm>
-            <a:off x="548640" y="1417319"/>
-            <a:ext cx="11064240" cy="4892040"/>
+            <a:off x="576000" y="2016000"/>
+            <a:ext cx="11052000" cy="3887999"/>
           </a:xfrm>
           <a:prstGeom prst="roundRect">
             <a:avLst/>
@@ -3523,6 +3529,9 @@
           <a:p>
             <a:pPr algn="ctr">
               <a:defRPr sz="1700">
+                <a:solidFill>
+                  <a:srgbClr val="30343B"/>
+                </a:solidFill>
                 <a:latin typeface="Roboto"/>
               </a:defRPr>
             </a:pPr>
@@ -3540,8 +3549,8 @@
         </p:nvSpPr>
         <p:spPr>
           <a:xfrm>
-            <a:off x="548640" y="6419160"/>
-            <a:ext cx="11064240" cy="301680"/>
+            <a:off x="576000" y="5904000"/>
+            <a:ext cx="11052000" cy="359999"/>
           </a:xfrm>
           <a:prstGeom prst="rect">
             <a:avLst/>
@@ -3602,8 +3611,8 @@
         </p:blipFill>
         <p:spPr>
           <a:xfrm>
-            <a:off x="10149840" y="320040"/>
-            <a:ext cx="1554480" cy="582765"/>
+            <a:off x="10571702" y="666000"/>
+            <a:ext cx="1056298" cy="396000"/>
           </a:xfrm>
           <a:prstGeom prst="rect">
             <a:avLst/>
@@ -3618,8 +3627,8 @@
         </p:nvSpPr>
         <p:spPr>
           <a:xfrm>
-            <a:off x="457199" y="457199"/>
-            <a:ext cx="9418320" cy="731520"/>
+            <a:off x="576000" y="1152000"/>
+            <a:ext cx="11052000" cy="864000"/>
           </a:xfrm>
           <a:prstGeom prst="rect">
             <a:avLst/>
@@ -3652,8 +3661,8 @@
         </p:nvSpPr>
         <p:spPr>
           <a:xfrm>
-            <a:off x="548640" y="1417319"/>
-            <a:ext cx="11064240" cy="4892040"/>
+            <a:off x="576000" y="2016000"/>
+            <a:ext cx="11052000" cy="3887999"/>
           </a:xfrm>
           <a:prstGeom prst="roundRect">
             <a:avLst/>
@@ -3687,6 +3696,9 @@
           <a:p>
             <a:pPr algn="ctr">
               <a:defRPr sz="1700">
+                <a:solidFill>
+                  <a:srgbClr val="30343B"/>
+                </a:solidFill>
                 <a:latin typeface="Roboto"/>
               </a:defRPr>
             </a:pPr>
@@ -3704,8 +3716,8 @@
         </p:nvSpPr>
         <p:spPr>
           <a:xfrm>
-            <a:off x="548640" y="6419160"/>
-            <a:ext cx="11064240" cy="301680"/>
+            <a:off x="576000" y="5904000"/>
+            <a:ext cx="11052000" cy="359999"/>
           </a:xfrm>
           <a:prstGeom prst="rect">
             <a:avLst/>
@@ -3766,8 +3778,8 @@
         </p:blipFill>
         <p:spPr>
           <a:xfrm>
-            <a:off x="10149840" y="320040"/>
-            <a:ext cx="1554480" cy="582765"/>
+            <a:off x="10571702" y="666000"/>
+            <a:ext cx="1056298" cy="396000"/>
           </a:xfrm>
           <a:prstGeom prst="rect">
             <a:avLst/>
@@ -3782,8 +3794,8 @@
         </p:nvSpPr>
         <p:spPr>
           <a:xfrm>
-            <a:off x="457199" y="457199"/>
-            <a:ext cx="9418320" cy="731520"/>
+            <a:off x="576000" y="1152000"/>
+            <a:ext cx="11052000" cy="864000"/>
           </a:xfrm>
           <a:prstGeom prst="rect">
             <a:avLst/>
@@ -3816,8 +3828,8 @@
         </p:nvSpPr>
         <p:spPr>
           <a:xfrm>
-            <a:off x="548640" y="1417319"/>
-            <a:ext cx="11064240" cy="4892040"/>
+            <a:off x="576000" y="2016000"/>
+            <a:ext cx="11052000" cy="3887999"/>
           </a:xfrm>
           <a:prstGeom prst="roundRect">
             <a:avLst/>
@@ -3851,6 +3863,9 @@
           <a:p>
             <a:pPr algn="ctr">
               <a:defRPr sz="1700">
+                <a:solidFill>
+                  <a:srgbClr val="30343B"/>
+                </a:solidFill>
                 <a:latin typeface="Roboto"/>
               </a:defRPr>
             </a:pPr>
@@ -3868,8 +3883,8 @@
         </p:nvSpPr>
         <p:spPr>
           <a:xfrm>
-            <a:off x="548640" y="6419160"/>
-            <a:ext cx="11064240" cy="301680"/>
+            <a:off x="576000" y="5904000"/>
+            <a:ext cx="11052000" cy="359999"/>
           </a:xfrm>
           <a:prstGeom prst="rect">
             <a:avLst/>
@@ -3930,8 +3945,8 @@
         </p:blipFill>
         <p:spPr>
           <a:xfrm>
-            <a:off x="10149840" y="320040"/>
-            <a:ext cx="1554480" cy="582765"/>
+            <a:off x="10571702" y="666000"/>
+            <a:ext cx="1056298" cy="396000"/>
           </a:xfrm>
           <a:prstGeom prst="rect">
             <a:avLst/>
@@ -3946,8 +3961,8 @@
         </p:nvSpPr>
         <p:spPr>
           <a:xfrm>
-            <a:off x="457199" y="457199"/>
-            <a:ext cx="9418320" cy="731520"/>
+            <a:off x="576000" y="1152000"/>
+            <a:ext cx="11052000" cy="864000"/>
           </a:xfrm>
           <a:prstGeom prst="rect">
             <a:avLst/>
@@ -3980,8 +3995,8 @@
         </p:nvSpPr>
         <p:spPr>
           <a:xfrm>
-            <a:off x="548640" y="1417319"/>
-            <a:ext cx="11064240" cy="4892040"/>
+            <a:off x="576000" y="2016000"/>
+            <a:ext cx="11052000" cy="3887999"/>
           </a:xfrm>
           <a:prstGeom prst="roundRect">
             <a:avLst/>
@@ -4015,6 +4030,9 @@
           <a:p>
             <a:pPr algn="ctr">
               <a:defRPr sz="1700">
+                <a:solidFill>
+                  <a:srgbClr val="30343B"/>
+                </a:solidFill>
                 <a:latin typeface="Roboto"/>
               </a:defRPr>
             </a:pPr>
@@ -4032,8 +4050,8 @@
         </p:nvSpPr>
         <p:spPr>
           <a:xfrm>
-            <a:off x="548640" y="6419160"/>
-            <a:ext cx="11064240" cy="301680"/>
+            <a:off x="576000" y="5904000"/>
+            <a:ext cx="11052000" cy="359999"/>
           </a:xfrm>
           <a:prstGeom prst="rect">
             <a:avLst/>
@@ -4094,8 +4112,8 @@
         </p:blipFill>
         <p:spPr>
           <a:xfrm>
-            <a:off x="10149840" y="320040"/>
-            <a:ext cx="1554480" cy="582765"/>
+            <a:off x="10571702" y="666000"/>
+            <a:ext cx="1056298" cy="396000"/>
           </a:xfrm>
           <a:prstGeom prst="rect">
             <a:avLst/>
@@ -4110,8 +4128,8 @@
         </p:nvSpPr>
         <p:spPr>
           <a:xfrm>
-            <a:off x="457199" y="457199"/>
-            <a:ext cx="9418320" cy="731520"/>
+            <a:off x="576000" y="1152000"/>
+            <a:ext cx="11052000" cy="864000"/>
           </a:xfrm>
           <a:prstGeom prst="rect">
             <a:avLst/>
@@ -4144,8 +4162,8 @@
         </p:nvSpPr>
         <p:spPr>
           <a:xfrm>
-            <a:off x="548640" y="1417319"/>
-            <a:ext cx="11064240" cy="4892040"/>
+            <a:off x="576000" y="2016000"/>
+            <a:ext cx="11052000" cy="3887999"/>
           </a:xfrm>
           <a:prstGeom prst="roundRect">
             <a:avLst/>
@@ -4179,6 +4197,9 @@
           <a:p>
             <a:pPr algn="ctr">
               <a:defRPr sz="1700">
+                <a:solidFill>
+                  <a:srgbClr val="30343B"/>
+                </a:solidFill>
                 <a:latin typeface="Roboto"/>
               </a:defRPr>
             </a:pPr>
@@ -4189,6 +4210,9 @@
           <a:p>
             <a:pPr>
               <a:defRPr sz="1700">
+                <a:solidFill>
+                  <a:srgbClr val="30343B"/>
+                </a:solidFill>
                 <a:latin typeface="Roboto"/>
               </a:defRPr>
             </a:pPr>
@@ -4206,8 +4230,8 @@
         </p:nvSpPr>
         <p:spPr>
           <a:xfrm>
-            <a:off x="548640" y="6419160"/>
-            <a:ext cx="11064240" cy="301680"/>
+            <a:off x="576000" y="5904000"/>
+            <a:ext cx="11052000" cy="359999"/>
           </a:xfrm>
           <a:prstGeom prst="rect">
             <a:avLst/>

</xml_diff>

<commit_message>
Adota Montserrat em todos os entregáveis e lê a fonte dos tokens
O corpo passa de Roboto para Montserrat (tokens 1.2.0). HTML e PDF deixam
de ter a família fixa no código e leem font_brand/font_body, como DOCX e
PPTX já faziam; o HTML só incorpora as famílias em uso. Gera as instâncias
estáticas Montserrat Regular e Medium para o ReportLab.

Tabelas genéricas do PDF passam a dimensionar as colunas pelo conteúdo,
garantindo que a palavra mais longa caiba, para a fonte mais larga não
quebrar palavras no meio. Regenera as 18 amostras e a referência 4D.

Co-Authored-By: Claude Opus 5.5 <noreply@anthropic.com>
</commit_message>
<xml_diff>
--- a/_SAMPLES_ENTREGAVEIS/executive_presentation/sample-executive-presentation-v1.0.0.pptx
+++ b/_SAMPLES_ENTREGAVEIS/executive_presentation/sample-executive-presentation-v1.0.0.pptx
@@ -3198,7 +3198,7 @@
                 <a:solidFill>
                   <a:srgbClr val="30343B"/>
                 </a:solidFill>
-                <a:latin typeface="Roboto"/>
+                <a:latin typeface="Montserrat"/>
               </a:defRPr>
             </a:pPr>
             <a:r>
@@ -3234,11 +3234,45 @@
                 <a:solidFill>
                   <a:srgbClr val="586EA4"/>
                 </a:solidFill>
-                <a:latin typeface="Roboto"/>
+                <a:latin typeface="Montserrat"/>
               </a:defRPr>
             </a:pPr>
             <a:r>
               <a:t>ID sample-executive-presentation · versão 1.0.0 · Completo</a:t>
+            </a:r>
+          </a:p>
+        </p:txBody>
+      </p:sp>
+      <p:sp>
+        <p:nvSpPr>
+          <p:cNvPr id="6" name="TextBox 5"/>
+          <p:cNvSpPr txBox="1"/>
+          <p:nvPr/>
+        </p:nvSpPr>
+        <p:spPr>
+          <a:xfrm>
+            <a:off x="576000" y="576000"/>
+            <a:ext cx="9540000" cy="576000"/>
+          </a:xfrm>
+          <a:prstGeom prst="rect">
+            <a:avLst/>
+          </a:prstGeom>
+          <a:noFill/>
+        </p:spPr>
+        <p:txBody>
+          <a:bodyPr wrap="none">
+            <a:spAutoFit/>
+          </a:bodyPr>
+          <a:lstStyle/>
+          <a:p>
+            <a:r>
+              <a:rPr sz="800">
+                <a:solidFill>
+                  <a:srgbClr val="4C73D1"/>
+                </a:solidFill>
+                <a:latin typeface="Montserrat"/>
+              </a:rPr>
+              <a:t>APRESENTAÇÃO EXECUTIVA</a:t>
             </a:r>
           </a:p>
         </p:txBody>
@@ -3365,7 +3399,7 @@
                 <a:solidFill>
                   <a:srgbClr val="30343B"/>
                 </a:solidFill>
-                <a:latin typeface="Roboto"/>
+                <a:latin typeface="Montserrat"/>
               </a:defRPr>
             </a:pPr>
             <a:r>
@@ -3401,11 +3435,45 @@
                 <a:solidFill>
                   <a:srgbClr val="586EA4"/>
                 </a:solidFill>
-                <a:latin typeface="Roboto"/>
+                <a:latin typeface="Montserrat"/>
               </a:defRPr>
             </a:pPr>
             <a:r>
               <a:t>ID sample-executive-presentation · versão 1.0.0 · Completo</a:t>
+            </a:r>
+          </a:p>
+        </p:txBody>
+      </p:sp>
+      <p:sp>
+        <p:nvSpPr>
+          <p:cNvPr id="6" name="TextBox 5"/>
+          <p:cNvSpPr txBox="1"/>
+          <p:nvPr/>
+        </p:nvSpPr>
+        <p:spPr>
+          <a:xfrm>
+            <a:off x="576000" y="576000"/>
+            <a:ext cx="9540000" cy="576000"/>
+          </a:xfrm>
+          <a:prstGeom prst="rect">
+            <a:avLst/>
+          </a:prstGeom>
+          <a:noFill/>
+        </p:spPr>
+        <p:txBody>
+          <a:bodyPr wrap="none">
+            <a:spAutoFit/>
+          </a:bodyPr>
+          <a:lstStyle/>
+          <a:p>
+            <a:r>
+              <a:rPr sz="800">
+                <a:solidFill>
+                  <a:srgbClr val="4C73D1"/>
+                </a:solidFill>
+                <a:latin typeface="Montserrat"/>
+              </a:rPr>
+              <a:t>APRESENTAÇÃO EXECUTIVA</a:t>
             </a:r>
           </a:p>
         </p:txBody>
@@ -3532,7 +3600,7 @@
                 <a:solidFill>
                   <a:srgbClr val="30343B"/>
                 </a:solidFill>
-                <a:latin typeface="Roboto"/>
+                <a:latin typeface="Montserrat"/>
               </a:defRPr>
             </a:pPr>
             <a:r>
@@ -3568,11 +3636,45 @@
                 <a:solidFill>
                   <a:srgbClr val="586EA4"/>
                 </a:solidFill>
-                <a:latin typeface="Roboto"/>
+                <a:latin typeface="Montserrat"/>
               </a:defRPr>
             </a:pPr>
             <a:r>
               <a:t>ID sample-executive-presentation · versão 1.0.0 · Completo</a:t>
+            </a:r>
+          </a:p>
+        </p:txBody>
+      </p:sp>
+      <p:sp>
+        <p:nvSpPr>
+          <p:cNvPr id="6" name="TextBox 5"/>
+          <p:cNvSpPr txBox="1"/>
+          <p:nvPr/>
+        </p:nvSpPr>
+        <p:spPr>
+          <a:xfrm>
+            <a:off x="576000" y="576000"/>
+            <a:ext cx="9540000" cy="576000"/>
+          </a:xfrm>
+          <a:prstGeom prst="rect">
+            <a:avLst/>
+          </a:prstGeom>
+          <a:noFill/>
+        </p:spPr>
+        <p:txBody>
+          <a:bodyPr wrap="none">
+            <a:spAutoFit/>
+          </a:bodyPr>
+          <a:lstStyle/>
+          <a:p>
+            <a:r>
+              <a:rPr sz="800">
+                <a:solidFill>
+                  <a:srgbClr val="4C73D1"/>
+                </a:solidFill>
+                <a:latin typeface="Montserrat"/>
+              </a:rPr>
+              <a:t>APRESENTAÇÃO EXECUTIVA</a:t>
             </a:r>
           </a:p>
         </p:txBody>
@@ -3699,7 +3801,7 @@
                 <a:solidFill>
                   <a:srgbClr val="30343B"/>
                 </a:solidFill>
-                <a:latin typeface="Roboto"/>
+                <a:latin typeface="Montserrat"/>
               </a:defRPr>
             </a:pPr>
             <a:r>
@@ -3735,11 +3837,45 @@
                 <a:solidFill>
                   <a:srgbClr val="586EA4"/>
                 </a:solidFill>
-                <a:latin typeface="Roboto"/>
+                <a:latin typeface="Montserrat"/>
               </a:defRPr>
             </a:pPr>
             <a:r>
               <a:t>ID sample-executive-presentation · versão 1.0.0 · Completo</a:t>
+            </a:r>
+          </a:p>
+        </p:txBody>
+      </p:sp>
+      <p:sp>
+        <p:nvSpPr>
+          <p:cNvPr id="6" name="TextBox 5"/>
+          <p:cNvSpPr txBox="1"/>
+          <p:nvPr/>
+        </p:nvSpPr>
+        <p:spPr>
+          <a:xfrm>
+            <a:off x="576000" y="576000"/>
+            <a:ext cx="9540000" cy="576000"/>
+          </a:xfrm>
+          <a:prstGeom prst="rect">
+            <a:avLst/>
+          </a:prstGeom>
+          <a:noFill/>
+        </p:spPr>
+        <p:txBody>
+          <a:bodyPr wrap="none">
+            <a:spAutoFit/>
+          </a:bodyPr>
+          <a:lstStyle/>
+          <a:p>
+            <a:r>
+              <a:rPr sz="800">
+                <a:solidFill>
+                  <a:srgbClr val="4C73D1"/>
+                </a:solidFill>
+                <a:latin typeface="Montserrat"/>
+              </a:rPr>
+              <a:t>APRESENTAÇÃO EXECUTIVA</a:t>
             </a:r>
           </a:p>
         </p:txBody>
@@ -3866,7 +4002,7 @@
                 <a:solidFill>
                   <a:srgbClr val="30343B"/>
                 </a:solidFill>
-                <a:latin typeface="Roboto"/>
+                <a:latin typeface="Montserrat"/>
               </a:defRPr>
             </a:pPr>
             <a:r>
@@ -3902,11 +4038,45 @@
                 <a:solidFill>
                   <a:srgbClr val="586EA4"/>
                 </a:solidFill>
-                <a:latin typeface="Roboto"/>
+                <a:latin typeface="Montserrat"/>
               </a:defRPr>
             </a:pPr>
             <a:r>
               <a:t>ID sample-executive-presentation · versão 1.0.0 · Completo</a:t>
+            </a:r>
+          </a:p>
+        </p:txBody>
+      </p:sp>
+      <p:sp>
+        <p:nvSpPr>
+          <p:cNvPr id="6" name="TextBox 5"/>
+          <p:cNvSpPr txBox="1"/>
+          <p:nvPr/>
+        </p:nvSpPr>
+        <p:spPr>
+          <a:xfrm>
+            <a:off x="576000" y="576000"/>
+            <a:ext cx="9540000" cy="576000"/>
+          </a:xfrm>
+          <a:prstGeom prst="rect">
+            <a:avLst/>
+          </a:prstGeom>
+          <a:noFill/>
+        </p:spPr>
+        <p:txBody>
+          <a:bodyPr wrap="none">
+            <a:spAutoFit/>
+          </a:bodyPr>
+          <a:lstStyle/>
+          <a:p>
+            <a:r>
+              <a:rPr sz="800">
+                <a:solidFill>
+                  <a:srgbClr val="4C73D1"/>
+                </a:solidFill>
+                <a:latin typeface="Montserrat"/>
+              </a:rPr>
+              <a:t>APRESENTAÇÃO EXECUTIVA</a:t>
             </a:r>
           </a:p>
         </p:txBody>
@@ -4033,7 +4203,7 @@
                 <a:solidFill>
                   <a:srgbClr val="30343B"/>
                 </a:solidFill>
-                <a:latin typeface="Roboto"/>
+                <a:latin typeface="Montserrat"/>
               </a:defRPr>
             </a:pPr>
             <a:r>
@@ -4069,11 +4239,45 @@
                 <a:solidFill>
                   <a:srgbClr val="586EA4"/>
                 </a:solidFill>
-                <a:latin typeface="Roboto"/>
+                <a:latin typeface="Montserrat"/>
               </a:defRPr>
             </a:pPr>
             <a:r>
               <a:t>ID sample-executive-presentation · versão 1.0.0 · Completo</a:t>
+            </a:r>
+          </a:p>
+        </p:txBody>
+      </p:sp>
+      <p:sp>
+        <p:nvSpPr>
+          <p:cNvPr id="6" name="TextBox 5"/>
+          <p:cNvSpPr txBox="1"/>
+          <p:nvPr/>
+        </p:nvSpPr>
+        <p:spPr>
+          <a:xfrm>
+            <a:off x="576000" y="576000"/>
+            <a:ext cx="9540000" cy="576000"/>
+          </a:xfrm>
+          <a:prstGeom prst="rect">
+            <a:avLst/>
+          </a:prstGeom>
+          <a:noFill/>
+        </p:spPr>
+        <p:txBody>
+          <a:bodyPr wrap="none">
+            <a:spAutoFit/>
+          </a:bodyPr>
+          <a:lstStyle/>
+          <a:p>
+            <a:r>
+              <a:rPr sz="800">
+                <a:solidFill>
+                  <a:srgbClr val="4C73D1"/>
+                </a:solidFill>
+                <a:latin typeface="Montserrat"/>
+              </a:rPr>
+              <a:t>APRESENTAÇÃO EXECUTIVA</a:t>
             </a:r>
           </a:p>
         </p:txBody>
@@ -4200,7 +4404,7 @@
                 <a:solidFill>
                   <a:srgbClr val="30343B"/>
                 </a:solidFill>
-                <a:latin typeface="Roboto"/>
+                <a:latin typeface="Montserrat"/>
               </a:defRPr>
             </a:pPr>
             <a:r>
@@ -4213,7 +4417,7 @@
                 <a:solidFill>
                   <a:srgbClr val="30343B"/>
                 </a:solidFill>
-                <a:latin typeface="Roboto"/>
+                <a:latin typeface="Montserrat"/>
               </a:defRPr>
             </a:pPr>
             <a:r>
@@ -4249,11 +4453,45 @@
                 <a:solidFill>
                   <a:srgbClr val="586EA4"/>
                 </a:solidFill>
-                <a:latin typeface="Roboto"/>
+                <a:latin typeface="Montserrat"/>
               </a:defRPr>
             </a:pPr>
             <a:r>
               <a:t>ID sample-executive-presentation · versão 1.0.0 · Completo</a:t>
+            </a:r>
+          </a:p>
+        </p:txBody>
+      </p:sp>
+      <p:sp>
+        <p:nvSpPr>
+          <p:cNvPr id="6" name="TextBox 5"/>
+          <p:cNvSpPr txBox="1"/>
+          <p:nvPr/>
+        </p:nvSpPr>
+        <p:spPr>
+          <a:xfrm>
+            <a:off x="576000" y="576000"/>
+            <a:ext cx="9540000" cy="576000"/>
+          </a:xfrm>
+          <a:prstGeom prst="rect">
+            <a:avLst/>
+          </a:prstGeom>
+          <a:noFill/>
+        </p:spPr>
+        <p:txBody>
+          <a:bodyPr wrap="none">
+            <a:spAutoFit/>
+          </a:bodyPr>
+          <a:lstStyle/>
+          <a:p>
+            <a:r>
+              <a:rPr sz="800">
+                <a:solidFill>
+                  <a:srgbClr val="4C73D1"/>
+                </a:solidFill>
+                <a:latin typeface="Montserrat"/>
+              </a:rPr>
+              <a:t>APRESENTAÇÃO EXECUTIVA</a:t>
             </a:r>
           </a:p>
         </p:txBody>

</xml_diff>

<commit_message>
Remove o travessão de todos os entregáveis e passa a recusá-lo
- O renderizador recusa conteúdo com travessão, meia-risca ou hífen com
  espaços e lista os campos (dash_paths); hífen de palavra e item de lista
  continuam válidos.
- O design system não gera mais travessão: rótulos dos Test Cards e
  Learning Cards, linha das fontes, células vazias, faixas de nota, texto
  dos cards e marcadores do modelo PPTX.
- O guia de linguagem, o SKILL.md de cada skill e o README do design
  system trazem a regra; referências, modelos de mural, manifesto de fontes,
  avisos de terceiros, scripts (IQB, preferências) e amostras foram
  reescritos sem travessão. Transcrições de fontes e LICENSE ficam como
  estão.
- Amostras regeneradas, incluindo os HTMLs antigos que estavam fora do
  ciclo de regeneração.

Co-Authored-By: Claude Opus 5.5 <noreply@anthropic.com>
</commit_message>
<xml_diff>
--- a/_SAMPLES_ENTREGAVEIS/executive_presentation/sample-executive-presentation-v1.0.0.pptx
+++ b/_SAMPLES_ENTREGAVEIS/executive_presentation/sample-executive-presentation-v1.0.0.pptx
@@ -2869,7 +2869,7 @@
           <a:spcPct val="20000"/>
         </a:spcBef>
         <a:buFont typeface="Arial"/>
-        <a:buChar char="–"/>
+        <a:buChar char="•"/>
         <a:defRPr sz="2800" kern="1200">
           <a:solidFill>
             <a:schemeClr val="tx1"/>
@@ -2899,7 +2899,7 @@
           <a:spcPct val="20000"/>
         </a:spcBef>
         <a:buFont typeface="Arial"/>
-        <a:buChar char="–"/>
+        <a:buChar char="•"/>
         <a:defRPr sz="2000" kern="1200">
           <a:solidFill>
             <a:schemeClr val="tx1"/>
@@ -3147,7 +3147,7 @@
                 </a:solidFill>
                 <a:latin typeface="Montserrat"/>
               </a:rPr>
-              <a:t>EXEMPLO FICTÍCIO — Entrada guiada nas solicitações de dados</a:t>
+              <a:t>EXEMPLO FICTÍCIO: Entrada guiada nas solicitações de dados</a:t>
             </a:r>
           </a:p>
         </p:txBody>
@@ -4408,7 +4408,7 @@
               </a:defRPr>
             </a:pPr>
             <a:r>
-              <a:t>FIC-01 — ata-simulada-5c, exemplo fictício, sem coleta real</a:t>
+              <a:t>FIC-01: ata-simulada-5c, exemplo fictício, sem coleta real</a:t>
             </a:r>
           </a:p>
           <a:p>
@@ -4421,7 +4421,7 @@
               </a:defRPr>
             </a:pPr>
             <a:r>
-              <a:t>FIC-02 — planilha-simulada, exemplo fictício, sem dados reais</a:t>
+              <a:t>FIC-02: planilha-simulada, exemplo fictício, sem dados reais</a:t>
             </a:r>
           </a:p>
         </p:txBody>

</xml_diff>